<commit_message>
Add supervised XLM-R-large ISE results and complete mid-report
Supervised XLM-R-large (1 epoch, full ISE train set):
  test hate F1=0.796, macro F1=0.816, FPR=0.228
Fills all placeholders in report/final_report/mid_report.tex.
Updates Discussion supervised-upper-bound paragraph from
conditional framing to definitive interpretation of results.
Adds configs/xlmr_large_ise_supervised.yaml training config.
Adds all ISE prediction files: zero-shot, few-shot K=8/16/32/64,
classical baselines, Level-2 fairness, and supervised.
Adds report assets: references.bib, icml2025 style files,
mid_report_no_supervised.tex fallback, preprocess_ise.py.
Updates few_shot_train.py, evaluator.py, few_shot_summary.csv.

Co-Authored-By: Claude Sonnet 4.6 <noreply@anthropic.com>
</commit_message>
<xml_diff>
--- a/report/AI600_HateSpeech_Presentation.pptx
+++ b/report/AI600_HateSpeech_Presentation.pptx
@@ -1302,7 +1302,7 @@
     <p:bg>
       <p:bgPr>
         <a:solidFill>
-          <a:srgbClr val="1C2B4A"/>
+          <a:srgbClr val="1E2761"/>
         </a:solidFill>
       </p:bgPr>
     </p:bg>
@@ -1335,11 +1335,11 @@
             <a:avLst/>
           </a:prstGeom>
           <a:solidFill>
-            <a:srgbClr val="0D9488"/>
+            <a:srgbClr val="F5A623"/>
           </a:solidFill>
           <a:ln w="12700">
             <a:solidFill>
-              <a:srgbClr val="0D9488"/>
+              <a:srgbClr val="F5A623"/>
             </a:solidFill>
             <a:prstDash val="solid"/>
           </a:ln>
@@ -1360,11 +1360,11 @@
             <a:avLst/>
           </a:prstGeom>
           <a:solidFill>
-            <a:srgbClr val="0D9488"/>
+            <a:srgbClr val="F5A623"/>
           </a:solidFill>
           <a:ln w="12700">
             <a:solidFill>
-              <a:srgbClr val="0D9488"/>
+              <a:srgbClr val="F5A623"/>
             </a:solidFill>
             <a:prstDash val="solid"/>
           </a:ln>
@@ -1385,11 +1385,11 @@
             <a:avLst/>
           </a:prstGeom>
           <a:solidFill>
-            <a:srgbClr val="0D9488"/>
+            <a:srgbClr val="F5A623"/>
           </a:solidFill>
           <a:ln w="12700">
             <a:solidFill>
-              <a:srgbClr val="0D9488"/>
+              <a:srgbClr val="F5A623"/>
             </a:solidFill>
             <a:prstDash val="solid"/>
           </a:ln>
@@ -1461,7 +1461,7 @@
             <a:r>
               <a:rPr lang="en-US" sz="1900" dirty="0">
                 <a:solidFill>
-                  <a:srgbClr val="CCFBF1"/>
+                  <a:srgbClr val="FDE68A"/>
                 </a:solidFill>
                 <a:latin typeface="Calibri" pitchFamily="34" charset="0"/>
                 <a:ea typeface="Calibri" pitchFamily="34" charset="-122"/>
@@ -1500,7 +1500,7 @@
             <a:r>
               <a:rPr lang="en-US" sz="1300" dirty="0">
                 <a:solidFill>
-                  <a:srgbClr val="94C5C0"/>
+                  <a:srgbClr val="C4A252"/>
                 </a:solidFill>
                 <a:latin typeface="Calibri" pitchFamily="34" charset="0"/>
                 <a:ea typeface="Calibri" pitchFamily="34" charset="-122"/>
@@ -1539,7 +1539,7 @@
             <a:r>
               <a:rPr lang="en-US" sz="1100" dirty="0">
                 <a:solidFill>
-                  <a:srgbClr val="FFFFFF"/>
+                  <a:srgbClr val="1E2761"/>
                 </a:solidFill>
                 <a:latin typeface="Calibri" pitchFamily="34" charset="0"/>
                 <a:ea typeface="Calibri" pitchFamily="34" charset="-122"/>
@@ -1565,7 +1565,7 @@
     <p:bg>
       <p:bgPr>
         <a:solidFill>
-          <a:srgbClr val="F5F6FA"/>
+          <a:srgbClr val="FAF9F6"/>
         </a:solidFill>
       </p:bgPr>
     </p:bg>
@@ -1598,11 +1598,11 @@
             <a:avLst/>
           </a:prstGeom>
           <a:solidFill>
-            <a:srgbClr val="0D9488"/>
+            <a:srgbClr val="F5A623"/>
           </a:solidFill>
           <a:ln w="12700">
             <a:solidFill>
-              <a:srgbClr val="0D9488"/>
+              <a:srgbClr val="F5A623"/>
             </a:solidFill>
             <a:prstDash val="solid"/>
           </a:ln>
@@ -1623,11 +1623,11 @@
             <a:avLst/>
           </a:prstGeom>
           <a:solidFill>
-            <a:srgbClr val="1C2B4A"/>
+            <a:srgbClr val="1E2761"/>
           </a:solidFill>
           <a:ln w="12700">
             <a:solidFill>
-              <a:srgbClr val="1C2B4A"/>
+              <a:srgbClr val="1E2761"/>
             </a:solidFill>
             <a:prstDash val="solid"/>
           </a:ln>
@@ -1704,13 +1704,13 @@
             <a:avLst/>
           </a:prstGeom>
           <a:solidFill>
-            <a:srgbClr val="0D9488">
+            <a:srgbClr val="F5A623">
               <a:alpha val="35000"/>
             </a:srgbClr>
           </a:solidFill>
           <a:ln w="12700">
             <a:solidFill>
-              <a:srgbClr val="0D9488">
+              <a:srgbClr val="F5A623">
                 <a:alpha val="35000"/>
               </a:srgbClr>
             </a:solidFill>
@@ -1745,7 +1745,7 @@
             <a:r>
               <a:rPr lang="en-US" sz="1700" b="1" dirty="0">
                 <a:solidFill>
-                  <a:srgbClr val="1C2B4A"/>
+                  <a:srgbClr val="1E2761"/>
                 </a:solidFill>
                 <a:latin typeface="Georgia" pitchFamily="34" charset="0"/>
                 <a:ea typeface="Georgia" pitchFamily="34" charset="-122"/>
@@ -1892,7 +1892,7 @@
             <a:r>
               <a:rPr lang="en-US" sz="1350" b="1" dirty="0">
                 <a:solidFill>
-                  <a:srgbClr val="1C2B4A"/>
+                  <a:srgbClr val="1E2761"/>
                 </a:solidFill>
                 <a:latin typeface="Georgia" pitchFamily="34" charset="0"/>
                 <a:ea typeface="Georgia" pitchFamily="34" charset="-122"/>
@@ -1919,11 +1919,11 @@
             <a:avLst/>
           </a:prstGeom>
           <a:solidFill>
-            <a:srgbClr val="0D9488"/>
+            <a:srgbClr val="F5A623"/>
           </a:solidFill>
           <a:ln w="12700">
             <a:solidFill>
-              <a:srgbClr val="0D9488"/>
+              <a:srgbClr val="F5A623"/>
             </a:solidFill>
             <a:prstDash val="solid"/>
           </a:ln>
@@ -1956,7 +1956,7 @@
             <a:r>
               <a:rPr lang="en-US" sz="1000" b="1" dirty="0">
                 <a:solidFill>
-                  <a:srgbClr val="FFFFFF"/>
+                  <a:srgbClr val="1E2761"/>
                 </a:solidFill>
                 <a:latin typeface="Calibri" pitchFamily="34" charset="0"/>
                 <a:ea typeface="Calibri" pitchFamily="34" charset="-122"/>
@@ -2022,11 +2022,11 @@
             <a:avLst/>
           </a:prstGeom>
           <a:solidFill>
-            <a:srgbClr val="0D9488"/>
+            <a:srgbClr val="F5A623"/>
           </a:solidFill>
           <a:ln w="12700">
             <a:solidFill>
-              <a:srgbClr val="0D9488"/>
+              <a:srgbClr val="F5A623"/>
             </a:solidFill>
             <a:prstDash val="solid"/>
           </a:ln>
@@ -2059,7 +2059,7 @@
             <a:r>
               <a:rPr lang="en-US" sz="1000" b="1" dirty="0">
                 <a:solidFill>
-                  <a:srgbClr val="FFFFFF"/>
+                  <a:srgbClr val="1E2761"/>
                 </a:solidFill>
                 <a:latin typeface="Calibri" pitchFamily="34" charset="0"/>
                 <a:ea typeface="Calibri" pitchFamily="34" charset="-122"/>
@@ -2125,11 +2125,11 @@
             <a:avLst/>
           </a:prstGeom>
           <a:solidFill>
-            <a:srgbClr val="0D9488"/>
+            <a:srgbClr val="F5A623"/>
           </a:solidFill>
           <a:ln w="12700">
             <a:solidFill>
-              <a:srgbClr val="0D9488"/>
+              <a:srgbClr val="F5A623"/>
             </a:solidFill>
             <a:prstDash val="solid"/>
           </a:ln>
@@ -2162,7 +2162,7 @@
             <a:r>
               <a:rPr lang="en-US" sz="1000" b="1" dirty="0">
                 <a:solidFill>
-                  <a:srgbClr val="FFFFFF"/>
+                  <a:srgbClr val="1E2761"/>
                 </a:solidFill>
                 <a:latin typeface="Calibri" pitchFamily="34" charset="0"/>
                 <a:ea typeface="Calibri" pitchFamily="34" charset="-122"/>
@@ -2228,11 +2228,11 @@
             <a:avLst/>
           </a:prstGeom>
           <a:solidFill>
-            <a:srgbClr val="0D9488"/>
+            <a:srgbClr val="F5A623"/>
           </a:solidFill>
           <a:ln w="12700">
             <a:solidFill>
-              <a:srgbClr val="0D9488"/>
+              <a:srgbClr val="F5A623"/>
             </a:solidFill>
             <a:prstDash val="solid"/>
           </a:ln>
@@ -2265,7 +2265,7 @@
             <a:r>
               <a:rPr lang="en-US" sz="1000" b="1" dirty="0">
                 <a:solidFill>
-                  <a:srgbClr val="FFFFFF"/>
+                  <a:srgbClr val="1E2761"/>
                 </a:solidFill>
                 <a:latin typeface="Calibri" pitchFamily="34" charset="0"/>
                 <a:ea typeface="Calibri" pitchFamily="34" charset="-122"/>
@@ -2330,7 +2330,7 @@
     <p:bg>
       <p:bgPr>
         <a:solidFill>
-          <a:srgbClr val="F5F6FA"/>
+          <a:srgbClr val="FAF9F6"/>
         </a:solidFill>
       </p:bgPr>
     </p:bg>
@@ -2363,11 +2363,11 @@
             <a:avLst/>
           </a:prstGeom>
           <a:solidFill>
-            <a:srgbClr val="0D9488"/>
+            <a:srgbClr val="F5A623"/>
           </a:solidFill>
           <a:ln w="12700">
             <a:solidFill>
-              <a:srgbClr val="0D9488"/>
+              <a:srgbClr val="F5A623"/>
             </a:solidFill>
             <a:prstDash val="solid"/>
           </a:ln>
@@ -2400,7 +2400,7 @@
             <a:r>
               <a:rPr lang="en-US" sz="2100" b="1" dirty="0">
                 <a:solidFill>
-                  <a:srgbClr val="1C2B4A"/>
+                  <a:srgbClr val="1E2761"/>
                 </a:solidFill>
                 <a:latin typeface="Georgia" pitchFamily="34" charset="0"/>
                 <a:ea typeface="Georgia" pitchFamily="34" charset="-122"/>
@@ -2459,11 +2459,11 @@
             <a:avLst/>
           </a:prstGeom>
           <a:solidFill>
-            <a:srgbClr val="1C2B4A"/>
+            <a:srgbClr val="1E2761"/>
           </a:solidFill>
           <a:ln w="12700">
             <a:solidFill>
-              <a:srgbClr val="1C2B4A"/>
+              <a:srgbClr val="1E2761"/>
             </a:solidFill>
             <a:prstDash val="solid"/>
           </a:ln>
@@ -3023,11 +3023,11 @@
             <a:avLst/>
           </a:prstGeom>
           <a:solidFill>
-            <a:srgbClr val="0D9488"/>
+            <a:srgbClr val="F5A623"/>
           </a:solidFill>
           <a:ln w="12700">
             <a:solidFill>
-              <a:srgbClr val="0D9488"/>
+              <a:srgbClr val="F5A623"/>
             </a:solidFill>
             <a:prstDash val="solid"/>
           </a:ln>
@@ -3060,7 +3060,7 @@
             <a:r>
               <a:rPr lang="en-US" sz="1200" b="1" dirty="0">
                 <a:solidFill>
-                  <a:srgbClr val="FFFFFF"/>
+                  <a:srgbClr val="1E2761"/>
                 </a:solidFill>
                 <a:latin typeface="Calibri" pitchFamily="34" charset="0"/>
                 <a:ea typeface="Calibri" pitchFamily="34" charset="-122"/>
@@ -3559,7 +3559,7 @@
           </a:solidFill>
           <a:ln w="12700">
             <a:solidFill>
-              <a:srgbClr val="F59E0B"/>
+              <a:srgbClr val="F5A623"/>
             </a:solidFill>
             <a:prstDash val="solid"/>
           </a:ln>
@@ -3632,7 +3632,7 @@
     <p:bg>
       <p:bgPr>
         <a:solidFill>
-          <a:srgbClr val="F5F6FA"/>
+          <a:srgbClr val="FAF9F6"/>
         </a:solidFill>
       </p:bgPr>
     </p:bg>
@@ -3665,11 +3665,11 @@
             <a:avLst/>
           </a:prstGeom>
           <a:solidFill>
-            <a:srgbClr val="0D9488"/>
+            <a:srgbClr val="F5A623"/>
           </a:solidFill>
           <a:ln w="12700">
             <a:solidFill>
-              <a:srgbClr val="0D9488"/>
+              <a:srgbClr val="F5A623"/>
             </a:solidFill>
             <a:prstDash val="solid"/>
           </a:ln>
@@ -3702,7 +3702,7 @@
             <a:r>
               <a:rPr lang="en-US" sz="2100" b="1" dirty="0">
                 <a:solidFill>
-                  <a:srgbClr val="1C2B4A"/>
+                  <a:srgbClr val="1E2761"/>
                 </a:solidFill>
                 <a:latin typeface="Georgia" pitchFamily="34" charset="0"/>
                 <a:ea typeface="Georgia" pitchFamily="34" charset="-122"/>
@@ -3935,11 +3935,11 @@
             <a:avLst/>
           </a:prstGeom>
           <a:solidFill>
-            <a:srgbClr val="1C2B4A"/>
+            <a:srgbClr val="1E2761"/>
           </a:solidFill>
           <a:ln w="12700">
             <a:solidFill>
-              <a:srgbClr val="1C2B4A"/>
+              <a:srgbClr val="1E2761"/>
             </a:solidFill>
             <a:prstDash val="solid"/>
           </a:ln>
@@ -3972,7 +3972,7 @@
             <a:r>
               <a:rPr lang="en-US" sz="1300" b="1" dirty="0">
                 <a:solidFill>
-                  <a:srgbClr val="1C2B4A"/>
+                  <a:srgbClr val="1E2761"/>
                 </a:solidFill>
                 <a:latin typeface="Calibri" pitchFamily="34" charset="0"/>
                 <a:ea typeface="Calibri" pitchFamily="34" charset="-122"/>
@@ -4050,7 +4050,7 @@
             <a:r>
               <a:rPr lang="en-US" sz="1050" b="1" dirty="0">
                 <a:solidFill>
-                  <a:srgbClr val="1C2B4A"/>
+                  <a:srgbClr val="1E2761"/>
                 </a:solidFill>
                 <a:latin typeface="Calibri" pitchFamily="34" charset="0"/>
                 <a:ea typeface="Calibri" pitchFamily="34" charset="-122"/>
@@ -4109,11 +4109,11 @@
             <a:avLst/>
           </a:prstGeom>
           <a:solidFill>
-            <a:srgbClr val="0D9488"/>
+            <a:srgbClr val="B45309"/>
           </a:solidFill>
           <a:ln w="12700">
             <a:solidFill>
-              <a:srgbClr val="0D9488"/>
+              <a:srgbClr val="B45309"/>
             </a:solidFill>
             <a:prstDash val="solid"/>
           </a:ln>
@@ -4146,7 +4146,7 @@
             <a:r>
               <a:rPr lang="en-US" sz="1300" b="1" dirty="0">
                 <a:solidFill>
-                  <a:srgbClr val="0D9488"/>
+                  <a:srgbClr val="B45309"/>
                 </a:solidFill>
                 <a:latin typeface="Calibri" pitchFamily="34" charset="0"/>
                 <a:ea typeface="Calibri" pitchFamily="34" charset="-122"/>
@@ -4224,7 +4224,7 @@
             <a:r>
               <a:rPr lang="en-US" sz="1050" b="1" dirty="0">
                 <a:solidFill>
-                  <a:srgbClr val="0D9488"/>
+                  <a:srgbClr val="B45309"/>
                 </a:solidFill>
                 <a:latin typeface="Calibri" pitchFamily="34" charset="0"/>
                 <a:ea typeface="Calibri" pitchFamily="34" charset="-122"/>
@@ -4263,7 +4263,7 @@
             <a:r>
               <a:rPr lang="en-US" sz="1300" b="1" dirty="0">
                 <a:solidFill>
-                  <a:srgbClr val="1C2B4A"/>
+                  <a:srgbClr val="1E2761"/>
                 </a:solidFill>
                 <a:latin typeface="Georgia" pitchFamily="34" charset="0"/>
                 <a:ea typeface="Georgia" pitchFamily="34" charset="-122"/>
@@ -4290,11 +4290,11 @@
             <a:avLst/>
           </a:prstGeom>
           <a:solidFill>
-            <a:srgbClr val="0D9488"/>
+            <a:srgbClr val="F5A623"/>
           </a:solidFill>
           <a:ln w="12700">
             <a:solidFill>
-              <a:srgbClr val="0D9488"/>
+              <a:srgbClr val="F5A623"/>
             </a:solidFill>
             <a:prstDash val="solid"/>
           </a:ln>
@@ -4327,7 +4327,7 @@
             <a:r>
               <a:rPr lang="en-US" sz="1150" b="1" dirty="0">
                 <a:solidFill>
-                  <a:srgbClr val="1C2B4A"/>
+                  <a:srgbClr val="1E2761"/>
                 </a:solidFill>
                 <a:latin typeface="Calibri" pitchFamily="34" charset="0"/>
                 <a:ea typeface="Calibri" pitchFamily="34" charset="-122"/>
@@ -4393,11 +4393,11 @@
             <a:avLst/>
           </a:prstGeom>
           <a:solidFill>
-            <a:srgbClr val="0D9488"/>
+            <a:srgbClr val="F5A623"/>
           </a:solidFill>
           <a:ln w="12700">
             <a:solidFill>
-              <a:srgbClr val="0D9488"/>
+              <a:srgbClr val="F5A623"/>
             </a:solidFill>
             <a:prstDash val="solid"/>
           </a:ln>
@@ -4430,7 +4430,7 @@
             <a:r>
               <a:rPr lang="en-US" sz="1150" b="1" dirty="0">
                 <a:solidFill>
-                  <a:srgbClr val="1C2B4A"/>
+                  <a:srgbClr val="1E2761"/>
                 </a:solidFill>
                 <a:latin typeface="Calibri" pitchFamily="34" charset="0"/>
                 <a:ea typeface="Calibri" pitchFamily="34" charset="-122"/>
@@ -4496,11 +4496,11 @@
             <a:avLst/>
           </a:prstGeom>
           <a:solidFill>
-            <a:srgbClr val="0D9488"/>
+            <a:srgbClr val="F5A623"/>
           </a:solidFill>
           <a:ln w="12700">
             <a:solidFill>
-              <a:srgbClr val="0D9488"/>
+              <a:srgbClr val="F5A623"/>
             </a:solidFill>
             <a:prstDash val="solid"/>
           </a:ln>
@@ -4533,7 +4533,7 @@
             <a:r>
               <a:rPr lang="en-US" sz="1150" b="1" dirty="0">
                 <a:solidFill>
-                  <a:srgbClr val="1C2B4A"/>
+                  <a:srgbClr val="1E2761"/>
                 </a:solidFill>
                 <a:latin typeface="Calibri" pitchFamily="34" charset="0"/>
                 <a:ea typeface="Calibri" pitchFamily="34" charset="-122"/>
@@ -4611,7 +4611,7 @@
             <a:r>
               <a:rPr lang="en-US" sz="1300" b="1" dirty="0">
                 <a:solidFill>
-                  <a:srgbClr val="1C2B4A"/>
+                  <a:srgbClr val="1E2761"/>
                 </a:solidFill>
                 <a:latin typeface="Georgia" pitchFamily="34" charset="0"/>
                 <a:ea typeface="Georgia" pitchFamily="34" charset="-122"/>
@@ -4797,11 +4797,11 @@
             <a:avLst/>
           </a:prstGeom>
           <a:solidFill>
-            <a:srgbClr val="EFF6FF"/>
+            <a:srgbClr val="FEF3C7"/>
           </a:solidFill>
           <a:ln w="6350">
             <a:solidFill>
-              <a:srgbClr val="BFDBFE"/>
+              <a:srgbClr val="F5A623"/>
             </a:solidFill>
             <a:prstDash val="solid"/>
           </a:ln>
@@ -4834,7 +4834,7 @@
             <a:r>
               <a:rPr lang="en-US" sz="1050" dirty="0">
                 <a:solidFill>
-                  <a:srgbClr val="1E40AF"/>
+                  <a:srgbClr val="92400E"/>
                 </a:solidFill>
                 <a:latin typeface="Calibri" pitchFamily="34" charset="0"/>
                 <a:ea typeface="Calibri" pitchFamily="34" charset="-122"/>
@@ -4860,7 +4860,7 @@
     <p:bg>
       <p:bgPr>
         <a:solidFill>
-          <a:srgbClr val="F5F6FA"/>
+          <a:srgbClr val="FAF9F6"/>
         </a:solidFill>
       </p:bgPr>
     </p:bg>
@@ -4893,11 +4893,11 @@
             <a:avLst/>
           </a:prstGeom>
           <a:solidFill>
-            <a:srgbClr val="0D9488"/>
+            <a:srgbClr val="F5A623"/>
           </a:solidFill>
           <a:ln w="12700">
             <a:solidFill>
-              <a:srgbClr val="0D9488"/>
+              <a:srgbClr val="F5A623"/>
             </a:solidFill>
             <a:prstDash val="solid"/>
           </a:ln>
@@ -4930,7 +4930,7 @@
             <a:r>
               <a:rPr lang="en-US" sz="2100" b="1" dirty="0">
                 <a:solidFill>
-                  <a:srgbClr val="1C2B4A"/>
+                  <a:srgbClr val="1E2761"/>
                 </a:solidFill>
                 <a:latin typeface="Georgia" pitchFamily="34" charset="0"/>
                 <a:ea typeface="Georgia" pitchFamily="34" charset="-122"/>
@@ -5075,7 +5075,7 @@
                       <a:tailEnd type="none" w="med" len="med"/>
                     </a:lnB>
                     <a:solidFill>
-                      <a:srgbClr val="1C2B4A"/>
+                      <a:srgbClr val="1E2761"/>
                     </a:solidFill>
                   </a:tcPr>
                 </a:tc>
@@ -5143,7 +5143,7 @@
                       <a:tailEnd type="none" w="med" len="med"/>
                     </a:lnB>
                     <a:solidFill>
-                      <a:srgbClr val="1C2B4A"/>
+                      <a:srgbClr val="1E2761"/>
                     </a:solidFill>
                   </a:tcPr>
                 </a:tc>
@@ -5211,7 +5211,7 @@
                       <a:tailEnd type="none" w="med" len="med"/>
                     </a:lnB>
                     <a:solidFill>
-                      <a:srgbClr val="1C2B4A"/>
+                      <a:srgbClr val="1E2761"/>
                     </a:solidFill>
                   </a:tcPr>
                 </a:tc>
@@ -5279,7 +5279,7 @@
                       <a:tailEnd type="none" w="med" len="med"/>
                     </a:lnB>
                     <a:solidFill>
-                      <a:srgbClr val="1C2B4A"/>
+                      <a:srgbClr val="1E2761"/>
                     </a:solidFill>
                   </a:tcPr>
                 </a:tc>
@@ -5347,7 +5347,7 @@
                       <a:tailEnd type="none" w="med" len="med"/>
                     </a:lnB>
                     <a:solidFill>
-                      <a:srgbClr val="1C2B4A"/>
+                      <a:srgbClr val="1E2761"/>
                     </a:solidFill>
                   </a:tcPr>
                 </a:tc>
@@ -6184,7 +6184,7 @@
                       <a:r>
                         <a:rPr lang="en-US" sz="1050" b="1" dirty="0">
                           <a:solidFill>
-                            <a:srgbClr val="0D9488"/>
+                            <a:srgbClr val="16A34A"/>
                           </a:solidFill>
                           <a:latin typeface="Calibri" pitchFamily="34" charset="0"/>
                           <a:ea typeface="Calibri" pitchFamily="34" charset="-122"/>
@@ -6252,7 +6252,7 @@
                       <a:r>
                         <a:rPr lang="en-US" sz="1050" b="1" dirty="0">
                           <a:solidFill>
-                            <a:srgbClr val="0D9488"/>
+                            <a:srgbClr val="16A34A"/>
                           </a:solidFill>
                           <a:latin typeface="Calibri" pitchFamily="34" charset="0"/>
                           <a:ea typeface="Calibri" pitchFamily="34" charset="-122"/>
@@ -6526,7 +6526,7 @@
                       <a:r>
                         <a:rPr lang="en-US" sz="1050" b="1" dirty="0">
                           <a:solidFill>
-                            <a:srgbClr val="1C2B4A"/>
+                            <a:srgbClr val="B45309"/>
                           </a:solidFill>
                           <a:latin typeface="Calibri" pitchFamily="34" charset="0"/>
                           <a:ea typeface="Calibri" pitchFamily="34" charset="-122"/>
@@ -6594,7 +6594,7 @@
                       <a:r>
                         <a:rPr lang="en-US" sz="1050" b="1" dirty="0">
                           <a:solidFill>
-                            <a:srgbClr val="1C2B4A"/>
+                            <a:srgbClr val="B45309"/>
                           </a:solidFill>
                           <a:latin typeface="Calibri" pitchFamily="34" charset="0"/>
                           <a:ea typeface="Calibri" pitchFamily="34" charset="-122"/>
@@ -6868,7 +6868,7 @@
                       <a:r>
                         <a:rPr lang="en-US" sz="1050" b="1" dirty="0">
                           <a:solidFill>
-                            <a:srgbClr val="1C2B4A"/>
+                            <a:srgbClr val="B45309"/>
                           </a:solidFill>
                           <a:latin typeface="Calibri" pitchFamily="34" charset="0"/>
                           <a:ea typeface="Calibri" pitchFamily="34" charset="-122"/>
@@ -6936,7 +6936,7 @@
                       <a:r>
                         <a:rPr lang="en-US" sz="1050" b="1" dirty="0">
                           <a:solidFill>
-                            <a:srgbClr val="1C2B4A"/>
+                            <a:srgbClr val="B45309"/>
                           </a:solidFill>
                           <a:latin typeface="Calibri" pitchFamily="34" charset="0"/>
                           <a:ea typeface="Calibri" pitchFamily="34" charset="-122"/>
@@ -7081,11 +7081,11 @@
             <a:avLst/>
           </a:prstGeom>
           <a:solidFill>
-            <a:srgbClr val="0D9488"/>
+            <a:srgbClr val="F5A623"/>
           </a:solidFill>
           <a:ln w="12700">
             <a:solidFill>
-              <a:srgbClr val="0D9488"/>
+              <a:srgbClr val="F5A623"/>
             </a:solidFill>
             <a:prstDash val="solid"/>
           </a:ln>
@@ -7106,11 +7106,11 @@
             <a:avLst/>
           </a:prstGeom>
           <a:solidFill>
-            <a:srgbClr val="1C2B4A"/>
+            <a:srgbClr val="1E2761"/>
           </a:solidFill>
           <a:ln w="12700">
             <a:solidFill>
-              <a:srgbClr val="1C2B4A"/>
+              <a:srgbClr val="1E2761"/>
             </a:solidFill>
             <a:prstDash val="solid"/>
           </a:ln>
@@ -7470,7 +7470,7 @@
     <p:bg>
       <p:bgPr>
         <a:solidFill>
-          <a:srgbClr val="1C2B4A"/>
+          <a:srgbClr val="1E2761"/>
         </a:solidFill>
       </p:bgPr>
     </p:bg>
@@ -7503,11 +7503,11 @@
             <a:avLst/>
           </a:prstGeom>
           <a:solidFill>
-            <a:srgbClr val="0D9488"/>
+            <a:srgbClr val="F5A623"/>
           </a:solidFill>
           <a:ln w="12700">
             <a:solidFill>
-              <a:srgbClr val="0D9488"/>
+              <a:srgbClr val="F5A623"/>
             </a:solidFill>
             <a:prstDash val="solid"/>
           </a:ln>
@@ -7567,11 +7567,11 @@
             <a:avLst/>
           </a:prstGeom>
           <a:solidFill>
-            <a:srgbClr val="0D9488"/>
+            <a:srgbClr val="F5A623"/>
           </a:solidFill>
           <a:ln w="12700">
             <a:solidFill>
-              <a:srgbClr val="0D9488"/>
+              <a:srgbClr val="F5A623"/>
             </a:solidFill>
             <a:prstDash val="solid"/>
           </a:ln>
@@ -7604,7 +7604,7 @@
             <a:r>
               <a:rPr lang="en-US" sz="1300" b="1" dirty="0">
                 <a:solidFill>
-                  <a:srgbClr val="FFFFFF"/>
+                  <a:srgbClr val="1E2761"/>
                 </a:solidFill>
                 <a:latin typeface="Calibri" pitchFamily="34" charset="0"/>
                 <a:ea typeface="Calibri" pitchFamily="34" charset="-122"/>
@@ -7670,11 +7670,11 @@
             <a:avLst/>
           </a:prstGeom>
           <a:solidFill>
-            <a:srgbClr val="0D9488"/>
+            <a:srgbClr val="F5A623"/>
           </a:solidFill>
           <a:ln w="12700">
             <a:solidFill>
-              <a:srgbClr val="0D9488"/>
+              <a:srgbClr val="F5A623"/>
             </a:solidFill>
             <a:prstDash val="solid"/>
           </a:ln>
@@ -7707,7 +7707,7 @@
             <a:r>
               <a:rPr lang="en-US" sz="1300" b="1" dirty="0">
                 <a:solidFill>
-                  <a:srgbClr val="FFFFFF"/>
+                  <a:srgbClr val="1E2761"/>
                 </a:solidFill>
                 <a:latin typeface="Calibri" pitchFamily="34" charset="0"/>
                 <a:ea typeface="Calibri" pitchFamily="34" charset="-122"/>
@@ -7773,11 +7773,11 @@
             <a:avLst/>
           </a:prstGeom>
           <a:solidFill>
-            <a:srgbClr val="0D9488"/>
+            <a:srgbClr val="F5A623"/>
           </a:solidFill>
           <a:ln w="12700">
             <a:solidFill>
-              <a:srgbClr val="0D9488"/>
+              <a:srgbClr val="F5A623"/>
             </a:solidFill>
             <a:prstDash val="solid"/>
           </a:ln>
@@ -7810,7 +7810,7 @@
             <a:r>
               <a:rPr lang="en-US" sz="1300" b="1" dirty="0">
                 <a:solidFill>
-                  <a:srgbClr val="FFFFFF"/>
+                  <a:srgbClr val="1E2761"/>
                 </a:solidFill>
                 <a:latin typeface="Calibri" pitchFamily="34" charset="0"/>
                 <a:ea typeface="Calibri" pitchFamily="34" charset="-122"/>
@@ -7876,11 +7876,11 @@
             <a:avLst/>
           </a:prstGeom>
           <a:solidFill>
-            <a:srgbClr val="0D9488"/>
+            <a:srgbClr val="F5A623"/>
           </a:solidFill>
           <a:ln w="12700">
             <a:solidFill>
-              <a:srgbClr val="0D9488"/>
+              <a:srgbClr val="F5A623"/>
             </a:solidFill>
             <a:prstDash val="solid"/>
           </a:ln>
@@ -7913,7 +7913,7 @@
             <a:r>
               <a:rPr lang="en-US" sz="1300" b="1" dirty="0">
                 <a:solidFill>
-                  <a:srgbClr val="FFFFFF"/>
+                  <a:srgbClr val="1E2761"/>
                 </a:solidFill>
                 <a:latin typeface="Calibri" pitchFamily="34" charset="0"/>
                 <a:ea typeface="Calibri" pitchFamily="34" charset="-122"/>
@@ -7979,11 +7979,11 @@
             <a:avLst/>
           </a:prstGeom>
           <a:solidFill>
-            <a:srgbClr val="0D9488"/>
+            <a:srgbClr val="F5A623"/>
           </a:solidFill>
           <a:ln w="12700">
             <a:solidFill>
-              <a:srgbClr val="0D9488"/>
+              <a:srgbClr val="F5A623"/>
             </a:solidFill>
             <a:prstDash val="solid"/>
           </a:ln>
@@ -8016,7 +8016,7 @@
             <a:r>
               <a:rPr lang="en-US" sz="1300" b="1" dirty="0">
                 <a:solidFill>
-                  <a:srgbClr val="FFFFFF"/>
+                  <a:srgbClr val="1E2761"/>
                 </a:solidFill>
                 <a:latin typeface="Calibri" pitchFamily="34" charset="0"/>
                 <a:ea typeface="Calibri" pitchFamily="34" charset="-122"/>
@@ -8082,11 +8082,11 @@
             <a:avLst/>
           </a:prstGeom>
           <a:solidFill>
-            <a:srgbClr val="0D9488"/>
+            <a:srgbClr val="F5A623"/>
           </a:solidFill>
           <a:ln w="12700">
             <a:solidFill>
-              <a:srgbClr val="0D9488"/>
+              <a:srgbClr val="F5A623"/>
             </a:solidFill>
             <a:prstDash val="solid"/>
           </a:ln>
@@ -8119,7 +8119,7 @@
             <a:r>
               <a:rPr lang="en-US" sz="1100" dirty="0">
                 <a:solidFill>
-                  <a:srgbClr val="FFFFFF"/>
+                  <a:srgbClr val="1E2761"/>
                 </a:solidFill>
                 <a:latin typeface="Calibri" pitchFamily="34" charset="0"/>
                 <a:ea typeface="Calibri" pitchFamily="34" charset="-122"/>

</xml_diff>